<commit_message>
Sprint 8: each team runs and audits its own live test (no cross-team checking); template updated
</commit_message>
<xml_diff>
--- a/assets/sprint8/sprint8-presentation-template.pptx
+++ b/assets/sprint8/sprint8-presentation-template.pptx
@@ -116,31 +116,31 @@
   <p:extLst>
     <p:ext uri="{521415D9-36F7-43E2-AB2F-B90AF26B5E84}">
       <p14:sectionLst xmlns:p14="http://schemas.microsoft.com/office/powerpoint/2010/main">
-        <p14:section name="Opening" id="{20ac423a-56a1-2a9f-0faa-171d0ccf4d04}">
+        <p14:section name="Opening" id="{d0af71ba-fe3f-6989-38c5-281af6a779bb}">
           <p14:sldIdLst>
             <p14:sldId id="256"/>
             <p14:sldId id="257"/>
           </p14:sldIdLst>
         </p14:section>
-        <p14:section name="Status" id="{bff724af-198d-6cbf-39b2-9d31c4df0ce8}">
+        <p14:section name="Status" id="{acbfb7c2-661d-85b5-f9b1-9a33fd4e7ee3}">
           <p14:sldIdLst>
             <p14:sldId id="258"/>
           </p14:sldIdLst>
         </p14:section>
-        <p14:section name="Live demo" id="{f0e9ebb3-f3ec-9ed0-2bef-8fafe3d3a8e1}">
+        <p14:section name="Live demo" id="{864fe66f-ceef-6d77-0448-6a2d3fb478c8}">
           <p14:sldIdLst>
             <p14:sldId id="259"/>
             <p14:sldId id="260"/>
             <p14:sldId id="261"/>
           </p14:sldIdLst>
         </p14:section>
-        <p14:section name="Evidence" id="{da5333c1-fe45-5f08-42c2-62252af89754}">
+        <p14:section name="Evidence" id="{f3299784-bd98-8cb1-1fa8-7047a7e951f9}">
           <p14:sldIdLst>
             <p14:sldId id="262"/>
             <p14:sldId id="263"/>
           </p14:sldIdLst>
         </p14:section>
-        <p14:section name="Team" id="{dffa7c84-f84c-2d19-177a-92fde0434a79}">
+        <p14:section name="Team" id="{26ab911e-7cff-ae63-06ec-b5248adf14b2}">
           <p14:sldIdLst>
             <p14:sldId id="264"/>
             <p14:sldId id="265"/>
@@ -550,7 +550,7 @@
           <a:p>
             <a:r>
               <a:rPr lang="en-US" dirty="0"/>
-              <a:t>Presenting R1 opens: team name, members by role, and the date. Keep it under 20 seconds.</a:t>
+              <a:t>R1 opens: team name, members by role, and the date. Keep it under 20 seconds.</a:t>
             </a:r>
             <a:endParaRPr lang="en-US" dirty="0"/>
           </a:p>
@@ -638,7 +638,7 @@
           <a:p>
             <a:r>
               <a:rPr lang="en-US" dirty="0"/>
-              <a:t>Presenting R1 closes. Then the teams swap: the checking team presents.</a:t>
+              <a:t>R1 closes. Then R4 commits docs/live-test.md the same day.</a:t>
             </a:r>
             <a:endParaRPr lang="en-US" dirty="0"/>
           </a:p>
@@ -726,7 +726,7 @@
           <a:p>
             <a:r>
               <a:rPr lang="en-US" dirty="0"/>
-              <a:t>Do not change this slide: every team runs the same order so the checking team can follow.</a:t>
+              <a:t>Do not change this slide: every team runs the same order.</a:t>
             </a:r>
             <a:endParaRPr lang="en-US" dirty="0"/>
           </a:p>
@@ -814,7 +814,7 @@
           <a:p>
             <a:r>
               <a:rPr lang="en-US" dirty="0"/>
-              <a:t>Be honest: the checking team tests every line. Started at Step B? Mark all eight Pass with the commit that proves it.</a:t>
+              <a:t>Be honest: R4 checks every line live. Started at Step B? Mark all eight Pass with the commit that proves it.</a:t>
             </a:r>
             <a:endParaRPr lang="en-US" dirty="0"/>
           </a:p>
@@ -1078,7 +1078,7 @@
           <a:p>
             <a:r>
               <a:rPr lang="en-US" dirty="0"/>
-              <a:t>Presenting R3. Labels: Confirmed (≥1.5× with the Summary), Warning (≥1.5× against it), Thin (&lt;0.7×), Normal (anything else).</a:t>
+              <a:t>R3. Labels: Confirmed (≥1.5× with the Summary), Warning (≥1.5× against it), Thin (&lt;0.7×), Normal (anything else).</a:t>
             </a:r>
             <a:endParaRPr lang="en-US" dirty="0"/>
           </a:p>
@@ -1166,7 +1166,7 @@
           <a:p>
             <a:r>
               <a:rPr lang="en-US" dirty="0"/>
-              <a:t>Presenting R4. Show the screenshot from docs/verify.md if asked.</a:t>
+              <a:t>R4. Show the screenshot from docs/verify.md if asked.</a:t>
             </a:r>
             <a:endParaRPr lang="en-US" dirty="0"/>
           </a:p>
@@ -1254,7 +1254,7 @@
           <a:p>
             <a:r>
               <a:rPr lang="en-US" dirty="0"/>
-              <a:t>Presenting R2. Locked values must match predictions/vW8.json, committed before Wednesday 23:59.</a:t>
+              <a:t>R2. Locked values must match predictions/vW8.json, committed before Wednesday 23:59.</a:t>
             </a:r>
             <a:endParaRPr lang="en-US" dirty="0"/>
           </a:p>
@@ -1342,7 +1342,7 @@
           <a:p>
             <a:r>
               <a:rPr lang="en-US" dirty="0"/>
-              <a:t>Presenting R1. Numbers must match GitHub; the checking team can open the repo to check.</a:t>
+              <a:t>R1. Numbers must match GitHub; anyone can open the repo to check.</a:t>
             </a:r>
             <a:endParaRPr lang="en-US" dirty="0"/>
           </a:p>
@@ -3145,7 +3145,7 @@
                           <a:ea typeface="Arial" pitchFamily="34" charset="-122"/>
                           <a:cs typeface="Arial" pitchFamily="34" charset="-120"/>
                         </a:rPr>
-                        <a:t>Presenting R1</a:t>
+                        <a:t>R1</a:t>
                       </a:r>
                       <a:endParaRPr lang="en-US" sz="1400" dirty="0">
                         <a:latin typeface="Arial" charset="0"/>
@@ -3351,7 +3351,7 @@
                           <a:ea typeface="Arial" pitchFamily="34" charset="-122"/>
                           <a:cs typeface="Arial" pitchFamily="34" charset="-120"/>
                         </a:rPr>
-                        <a:t>Presenting R6, R5</a:t>
+                        <a:t>R6, R5, R4</a:t>
                       </a:r>
                       <a:endParaRPr lang="en-US" sz="1400" dirty="0">
                         <a:latin typeface="Arial" charset="0"/>
@@ -3489,7 +3489,7 @@
                           <a:ea typeface="Arial" pitchFamily="34" charset="-122"/>
                           <a:cs typeface="Arial" pitchFamily="34" charset="-120"/>
                         </a:rPr>
-                        <a:t>One indicator explained (row and member chosen by the checking team)</a:t>
+                        <a:t>One indicator explained (row and member drawn at random by R1)</a:t>
                       </a:r>
                       <a:endParaRPr lang="en-US" sz="1400" dirty="0">
                         <a:latin typeface="Arial" charset="0"/>
@@ -3557,7 +3557,7 @@
                           <a:ea typeface="Arial" pitchFamily="34" charset="-122"/>
                           <a:cs typeface="Arial" pitchFamily="34" charset="-120"/>
                         </a:rPr>
-                        <a:t>Checking team picks</a:t>
+                        <a:t>Drawn by R1, explained by that member</a:t>
                       </a:r>
                       <a:endParaRPr lang="en-US" sz="1400" dirty="0">
                         <a:latin typeface="Arial" charset="0"/>
@@ -3763,7 +3763,7 @@
                           <a:ea typeface="Arial" pitchFamily="34" charset="-122"/>
                           <a:cs typeface="Arial" pitchFamily="34" charset="-120"/>
                         </a:rPr>
-                        <a:t>Presenting R3</a:t>
+                        <a:t>R3</a:t>
                       </a:r>
                       <a:endParaRPr lang="en-US" sz="1400" dirty="0">
                         <a:latin typeface="Arial" charset="0"/>
@@ -3969,7 +3969,7 @@
                           <a:ea typeface="Arial" pitchFamily="34" charset="-122"/>
                           <a:cs typeface="Arial" pitchFamily="34" charset="-120"/>
                         </a:rPr>
-                        <a:t>Presenting R4</a:t>
+                        <a:t>R4</a:t>
                       </a:r>
                       <a:endParaRPr lang="en-US" sz="1400" dirty="0">
                         <a:latin typeface="Arial" charset="0"/>
@@ -4175,7 +4175,7 @@
                           <a:ea typeface="Arial" pitchFamily="34" charset="-122"/>
                           <a:cs typeface="Arial" pitchFamily="34" charset="-120"/>
                         </a:rPr>
-                        <a:t>Presenting R2</a:t>
+                        <a:t>R2</a:t>
                       </a:r>
                       <a:endParaRPr lang="en-US" sz="1400" dirty="0">
                         <a:latin typeface="Arial" charset="0"/>
@@ -4381,7 +4381,7 @@
                           <a:ea typeface="Arial" pitchFamily="34" charset="-122"/>
                           <a:cs typeface="Arial" pitchFamily="34" charset="-120"/>
                         </a:rPr>
-                        <a:t>Presenting R1</a:t>
+                        <a:t>R1</a:t>
                       </a:r>
                       <a:endParaRPr lang="en-US" sz="1400" dirty="0">
                         <a:latin typeface="Arial" charset="0"/>
@@ -7388,7 +7388,7 @@
                   <a:srgbClr val="EEF2F6"/>
                 </a:solidFill>
               </a:rPr>
-              <a:t>3. Checking R4 compares one timeframe with Investing.com</a:t>
+              <a:t>3. R4 compares one timeframe with Investing.com</a:t>
             </a:r>
             <a:endParaRPr lang="en-US" sz="1600" dirty="0"/>
           </a:p>
@@ -7568,7 +7568,7 @@
                   <a:srgbClr val="5B6675"/>
                 </a:solidFill>
               </a:rPr>
-              <a:t>The checking team picks the row and the member. Using the reference engine? Prepare one copy of this slide per member.</a:t>
+              <a:t>R1 draws the row and the member at random, on screen. Using the reference engine? Prepare one copy of this slide per member.</a:t>
             </a:r>
             <a:endParaRPr lang="en-US" sz="1500" dirty="0"/>
           </a:p>

</xml_diff>

<commit_message>
Sprint 8: Practical A teams check each other in rotation (1->2->3->1); Team 4 self-audits; template updated
</commit_message>
<xml_diff>
--- a/assets/sprint8/sprint8-presentation-template.pptx
+++ b/assets/sprint8/sprint8-presentation-template.pptx
@@ -116,31 +116,31 @@
   <p:extLst>
     <p:ext uri="{521415D9-36F7-43E2-AB2F-B90AF26B5E84}">
       <p14:sectionLst xmlns:p14="http://schemas.microsoft.com/office/powerpoint/2010/main">
-        <p14:section name="Opening" id="{d0af71ba-fe3f-6989-38c5-281af6a779bb}">
+        <p14:section name="Opening" id="{23c74520-ab80-60bf-9c4a-a3d9bc3137b9}">
           <p14:sldIdLst>
             <p14:sldId id="256"/>
             <p14:sldId id="257"/>
           </p14:sldIdLst>
         </p14:section>
-        <p14:section name="Status" id="{acbfb7c2-661d-85b5-f9b1-9a33fd4e7ee3}">
+        <p14:section name="Status" id="{27c1bfd4-f557-800d-803e-e20b04ab75c8}">
           <p14:sldIdLst>
             <p14:sldId id="258"/>
           </p14:sldIdLst>
         </p14:section>
-        <p14:section name="Live demo" id="{864fe66f-ceef-6d77-0448-6a2d3fb478c8}">
+        <p14:section name="Live demo" id="{4d6d31c8-6fd3-3550-6312-ed430aac9dec}">
           <p14:sldIdLst>
             <p14:sldId id="259"/>
             <p14:sldId id="260"/>
             <p14:sldId id="261"/>
           </p14:sldIdLst>
         </p14:section>
-        <p14:section name="Evidence" id="{f3299784-bd98-8cb1-1fa8-7047a7e951f9}">
+        <p14:section name="Evidence" id="{91b5e614-bc21-a0df-857b-f1fa70213fa1}">
           <p14:sldIdLst>
             <p14:sldId id="262"/>
             <p14:sldId id="263"/>
           </p14:sldIdLst>
         </p14:section>
-        <p14:section name="Team" id="{26ab911e-7cff-ae63-06ec-b5248adf14b2}">
+        <p14:section name="Team" id="{1fbd9716-e3a7-434c-c959-47ce8a870ef8}">
           <p14:sldIdLst>
             <p14:sldId id="264"/>
             <p14:sldId id="265"/>
@@ -814,7 +814,7 @@
           <a:p>
             <a:r>
               <a:rPr lang="en-US" dirty="0"/>
-              <a:t>Be honest: R4 checks every line live. Started at Step B? Mark all eight Pass with the commit that proves it.</a:t>
+              <a:t>Be honest: the checker's R4 tests every line live. Started at Step B? Mark all eight Pass with the commit that proves it.</a:t>
             </a:r>
             <a:endParaRPr lang="en-US" dirty="0"/>
           </a:p>
@@ -3489,7 +3489,7 @@
                           <a:ea typeface="Arial" pitchFamily="34" charset="-122"/>
                           <a:cs typeface="Arial" pitchFamily="34" charset="-120"/>
                         </a:rPr>
-                        <a:t>One indicator explained (row and member drawn at random by R1)</a:t>
+                        <a:t>One indicator explained (row and member drawn at random)</a:t>
                       </a:r>
                       <a:endParaRPr lang="en-US" sz="1400" dirty="0">
                         <a:latin typeface="Arial" charset="0"/>
@@ -3557,7 +3557,7 @@
                           <a:ea typeface="Arial" pitchFamily="34" charset="-122"/>
                           <a:cs typeface="Arial" pitchFamily="34" charset="-120"/>
                         </a:rPr>
-                        <a:t>Drawn by R1, explained by that member</a:t>
+                        <a:t>Drawn by the checker's R4</a:t>
                       </a:r>
                       <a:endParaRPr lang="en-US" sz="1400" dirty="0">
                         <a:latin typeface="Arial" charset="0"/>
@@ -7388,7 +7388,7 @@
                   <a:srgbClr val="EEF2F6"/>
                 </a:solidFill>
               </a:rPr>
-              <a:t>3. R4 compares one timeframe with Investing.com</a:t>
+              <a:t>3. The checker's R4 compares one timeframe with Investing.com</a:t>
             </a:r>
             <a:endParaRPr lang="en-US" sz="1600" dirty="0"/>
           </a:p>
@@ -7568,7 +7568,7 @@
                   <a:srgbClr val="5B6675"/>
                 </a:solidFill>
               </a:rPr>
-              <a:t>R1 draws the row and the member at random, on screen. Using the reference engine? Prepare one copy of this slide per member.</a:t>
+              <a:t>The checker's R4 draws the row and the member at random, on screen (another team in Practical A; Team 4's own R4). Using the reference engine? Prepare one copy of this slide per member.</a:t>
             </a:r>
             <a:endParaRPr lang="en-US" sz="1500" dirty="0"/>
           </a:p>

</xml_diff>